<commit_message>
Update funding breakdown with realistic DFS licensing costs ($80K)
Research shows Canadian DFS licensing/legal compliance runs $65K-$135K
for Year 1 (Criminal Code opinion $15-25K, gaming counsel retainer
$30-60K, contest rules $15-40K, regulatory monitoring $5-10K).

Updated allocation to $80K (32%) for licensing — now the largest
line item, reflecting the true cost of operating legally.

New $250K breakdown:
- Licensing, Legal & Compliance: $80K (32%)
- Marketing & UA: $65K (26%)
- Team / Contractors: $50K (20%)
- Infrastructure: $25K (10%)
- Operating Reserve: $30K (12%)

https://claude.ai/code/session_01W6kNMkpS7XiGU5R6Nuc7yU
</commit_message>
<xml_diff>
--- a/docs/Citrus_Pitch_Deck.pptx
+++ b/docs/Citrus_Pitch_Deck.pptx
@@ -3635,7 +3635,7 @@
               </a:defRPr>
             </a:pPr>
             <a:r>
-              <a:t>Marketing &amp; User Acquisition</a:t>
+              <a:t>Licensing, Legal &amp; Compliance</a:t>
             </a:r>
           </a:p>
         </p:txBody>
@@ -3669,7 +3669,7 @@
               </a:defRPr>
             </a:pPr>
             <a:r>
-              <a:t>$85K</a:t>
+              <a:t>$80K</a:t>
             </a:r>
           </a:p>
         </p:txBody>
@@ -3703,7 +3703,7 @@
               </a:defRPr>
             </a:pPr>
             <a:r>
-              <a:t>Paid channels, influencer/content partnerships, Oct 2026 season push</a:t>
+              <a:t>Criminal Code opinion, gaming counsel retainer, contest rules, DFS regulatory filings</a:t>
             </a:r>
           </a:p>
         </p:txBody>
@@ -3793,7 +3793,7 @@
               </a:defRPr>
             </a:pPr>
             <a:r>
-              <a:t>Team / Engineering Contractors</a:t>
+              <a:t>Marketing &amp; User Acquisition</a:t>
             </a:r>
           </a:p>
         </p:txBody>
@@ -3827,7 +3827,7 @@
               </a:defRPr>
             </a:pPr>
             <a:r>
-              <a:t>$60K</a:t>
+              <a:t>$65K</a:t>
             </a:r>
           </a:p>
         </p:txBody>
@@ -3861,7 +3861,7 @@
               </a:defRPr>
             </a:pPr>
             <a:r>
-              <a:t>Pull hiring forward to Month 4. Accelerate product velocity.</a:t>
+              <a:t>Paid channels, influencer/content partnerships, Oct 2026 season push</a:t>
             </a:r>
           </a:p>
         </p:txBody>
@@ -3951,7 +3951,7 @@
               </a:defRPr>
             </a:pPr>
             <a:r>
-              <a:t>DFS Licensing &amp; Legal (Alberta)</a:t>
+              <a:t>Team / Engineering Contractors</a:t>
             </a:r>
           </a:p>
         </p:txBody>
@@ -3985,7 +3985,7 @@
               </a:defRPr>
             </a:pPr>
             <a:r>
-              <a:t>$40K</a:t>
+              <a:t>$50K</a:t>
             </a:r>
           </a:p>
         </p:txBody>
@@ -4019,7 +4019,7 @@
               </a:defRPr>
             </a:pPr>
             <a:r>
-              <a:t>AGLC compliance, gaming counsel, provincial licensing applications</a:t>
+              <a:t>Pull hiring forward to Month 4. Accelerate product velocity.</a:t>
             </a:r>
           </a:p>
         </p:txBody>
@@ -4143,7 +4143,7 @@
               </a:defRPr>
             </a:pPr>
             <a:r>
-              <a:t>$30K</a:t>
+              <a:t>$25K</a:t>
             </a:r>
           </a:p>
         </p:txBody>
@@ -4301,7 +4301,7 @@
               </a:defRPr>
             </a:pPr>
             <a:r>
-              <a:t>$35K</a:t>
+              <a:t>$30K</a:t>
             </a:r>
           </a:p>
         </p:txBody>
@@ -4582,7 +4582,7 @@
               </a:defRPr>
             </a:pPr>
             <a:r>
-              <a:t>Massive LTV:CAC</a:t>
+              <a:t>Legally buttoned up</a:t>
             </a:r>
           </a:p>
         </p:txBody>
@@ -4616,7 +4616,7 @@
               </a:defRPr>
             </a:pPr>
             <a:r>
-              <a:t>$2.50 CAC vs DraftKings' $200+. LTV:CAC ratio hits 10x+ in-season</a:t>
+              <a:t>$80K for gaming counsel, Criminal Code opinion, contest rules — no shortcuts</a:t>
             </a:r>
           </a:p>
         </p:txBody>
@@ -4650,7 +4650,7 @@
               </a:defRPr>
             </a:pPr>
             <a:r>
-              <a:t>97% gross margins</a:t>
+              <a:t>Massive LTV:CAC</a:t>
             </a:r>
           </a:p>
         </p:txBody>
@@ -4684,7 +4684,7 @@
               </a:defRPr>
             </a:pPr>
             <a:r>
-              <a:t>Pure software. Near-zero marginal COGS at scale</a:t>
+              <a:t>$2.50 CAC vs DraftKings’ $200+. LTV:CAC ratio hits 10x+ in-season</a:t>
             </a:r>
           </a:p>
         </p:txBody>
@@ -4718,7 +4718,7 @@
               </a:defRPr>
             </a:pPr>
             <a:r>
-              <a:t>No Series A needed</a:t>
+              <a:t>97% gross margins</a:t>
             </a:r>
           </a:p>
         </p:txBody>
@@ -4752,7 +4752,7 @@
               </a:defRPr>
             </a:pPr>
             <a:r>
-              <a:t>Model shows self-sustainability. Raise again only from strength</a:t>
+              <a:t>Pure software. Near-zero marginal COGS at scale</a:t>
             </a:r>
           </a:p>
         </p:txBody>

</xml_diff>